<commit_message>
03-26-26 - Finished module 1 lecture and worksheets
</commit_message>
<xml_diff>
--- a/lectures/module_01_what_is_a_chip.pptx
+++ b/lectures/module_01_what_is_a_chip.pptx
@@ -5,10 +5,10 @@
     <p:sldMasterId id="2147483648" r:id="rId1"/>
   </p:sldMasterIdLst>
   <p:notesMasterIdLst>
-    <p:notesMasterId r:id="rId9"/>
+    <p:notesMasterId r:id="rId13"/>
   </p:notesMasterIdLst>
   <p:handoutMasterIdLst>
-    <p:handoutMasterId r:id="rId10"/>
+    <p:handoutMasterId r:id="rId14"/>
   </p:handoutMasterIdLst>
   <p:sldIdLst>
     <p:sldId id="258" r:id="rId2"/>
@@ -18,6 +18,10 @@
     <p:sldId id="276" r:id="rId6"/>
     <p:sldId id="277" r:id="rId7"/>
     <p:sldId id="278" r:id="rId8"/>
+    <p:sldId id="279" r:id="rId9"/>
+    <p:sldId id="280" r:id="rId10"/>
+    <p:sldId id="282" r:id="rId11"/>
+    <p:sldId id="281" r:id="rId12"/>
   </p:sldIdLst>
   <p:sldSz cx="12192000" cy="6858000"/>
   <p:notesSz cx="9220200" cy="6934200"/>
@@ -221,7 +225,7 @@
           <a:p>
             <a:fld id="{235382CB-D6B4-48E5-AFFD-4242D787BD27}" type="datetime2">
               <a:rPr lang="en-US" smtClean="0"/>
-              <a:t>Wednesday, February 11, 2026</a:t>
+              <a:t>Thursday, March 26, 2026</a:t>
             </a:fld>
             <a:endParaRPr lang="en-US"/>
           </a:p>
@@ -405,7 +409,7 @@
           <a:p>
             <a:fld id="{F76BFB3A-AF09-4935-935F-AADA8F949CAB}" type="datetime2">
               <a:rPr lang="en-US" smtClean="0"/>
-              <a:t>Wednesday, February 11, 2026</a:t>
+              <a:t>Thursday, March 26, 2026</a:t>
             </a:fld>
             <a:endParaRPr lang="en-US"/>
           </a:p>
@@ -13018,7 +13022,7 @@
           <a:p>
             <a:r>
               <a:rPr lang="en-US" sz="3600" dirty="0"/>
-              <a:t>What Is a Semiconductor Chip?</a:t>
+              <a:t>What Is a Chip?</a:t>
             </a:r>
           </a:p>
         </p:txBody>
@@ -13082,6 +13086,221 @@
     <p:extLst>
       <p:ext uri="{BB962C8B-B14F-4D97-AF65-F5344CB8AC3E}">
         <p14:creationId xmlns:p14="http://schemas.microsoft.com/office/powerpoint/2010/main" val="10789577"/>
+      </p:ext>
+    </p:extLst>
+  </p:cSld>
+  <p:clrMapOvr>
+    <a:masterClrMapping/>
+  </p:clrMapOvr>
+</p:sld>
+</file>
+
+<file path=ppt/slides/slide10.xml><?xml version="1.0" encoding="utf-8"?>
+<p:sld xmlns:a="http://schemas.openxmlformats.org/drawingml/2006/main" xmlns:r="http://schemas.openxmlformats.org/officeDocument/2006/relationships" xmlns:p="http://schemas.openxmlformats.org/presentationml/2006/main">
+  <p:cSld>
+    <p:spTree>
+      <p:nvGrpSpPr>
+        <p:cNvPr id="1" name=""/>
+        <p:cNvGrpSpPr/>
+        <p:nvPr/>
+      </p:nvGrpSpPr>
+      <p:grpSpPr>
+        <a:xfrm>
+          <a:off x="0" y="0"/>
+          <a:ext cx="0" cy="0"/>
+          <a:chOff x="0" y="0"/>
+          <a:chExt cx="0" cy="0"/>
+        </a:xfrm>
+      </p:grpSpPr>
+      <p:sp>
+        <p:nvSpPr>
+          <p:cNvPr id="5" name="Title 4">
+            <a:extLst>
+              <a:ext uri="{FF2B5EF4-FFF2-40B4-BE49-F238E27FC236}">
+                <a16:creationId xmlns:a16="http://schemas.microsoft.com/office/drawing/2014/main" id="{96CE330F-915C-8781-9622-8A165317AFE3}"/>
+              </a:ext>
+            </a:extLst>
+          </p:cNvPr>
+          <p:cNvSpPr>
+            <a:spLocks noGrp="1"/>
+          </p:cNvSpPr>
+          <p:nvPr>
+            <p:ph type="title"/>
+          </p:nvPr>
+        </p:nvSpPr>
+        <p:spPr/>
+        <p:txBody>
+          <a:bodyPr/>
+          <a:lstStyle/>
+          <a:p>
+            <a:pPr algn="ctr"/>
+            <a:r>
+              <a:rPr lang="en-US" dirty="0"/>
+              <a:t>Video: Inside the Cleanroom</a:t>
+            </a:r>
+            <a:br>
+              <a:rPr lang="en-US" dirty="0"/>
+            </a:br>
+            <a:r>
+              <a:rPr lang="en-US" dirty="0"/>
+              <a:t>How Chips Get Made</a:t>
+            </a:r>
+          </a:p>
+        </p:txBody>
+      </p:sp>
+      <p:pic>
+        <p:nvPicPr>
+          <p:cNvPr id="8" name="Content Placeholder 7">
+            <a:hlinkClick r:id="rId2"/>
+            <a:extLst>
+              <a:ext uri="{FF2B5EF4-FFF2-40B4-BE49-F238E27FC236}">
+                <a16:creationId xmlns:a16="http://schemas.microsoft.com/office/drawing/2014/main" id="{25BBAB2C-CDA0-3FB1-5965-5994BD76DF1B}"/>
+              </a:ext>
+              <a:ext uri="{C183D7F6-B498-43B3-948B-1728B52AA6E4}">
+                <adec:decorative xmlns:adec="http://schemas.microsoft.com/office/drawing/2017/decorative" val="1"/>
+              </a:ext>
+            </a:extLst>
+          </p:cNvPr>
+          <p:cNvPicPr>
+            <a:picLocks noGrp="1" noChangeAspect="1"/>
+          </p:cNvPicPr>
+          <p:nvPr>
+            <p:ph idx="1"/>
+          </p:nvPr>
+        </p:nvPicPr>
+        <p:blipFill>
+          <a:blip r:embed="rId3"/>
+          <a:stretch>
+            <a:fillRect/>
+          </a:stretch>
+        </p:blipFill>
+        <p:spPr>
+          <a:xfrm>
+            <a:off x="2147925" y="1828800"/>
+            <a:ext cx="7888212" cy="4359275"/>
+          </a:xfrm>
+          <a:prstGeom prst="rect">
+            <a:avLst/>
+          </a:prstGeom>
+          <a:ln w="28575">
+            <a:solidFill>
+              <a:schemeClr val="tx2"/>
+            </a:solidFill>
+          </a:ln>
+        </p:spPr>
+      </p:pic>
+    </p:spTree>
+    <p:extLst>
+      <p:ext uri="{BB962C8B-B14F-4D97-AF65-F5344CB8AC3E}">
+        <p14:creationId xmlns:p14="http://schemas.microsoft.com/office/powerpoint/2010/main" val="304105440"/>
+      </p:ext>
+    </p:extLst>
+  </p:cSld>
+  <p:clrMapOvr>
+    <a:masterClrMapping/>
+  </p:clrMapOvr>
+</p:sld>
+</file>
+
+<file path=ppt/slides/slide11.xml><?xml version="1.0" encoding="utf-8"?>
+<p:sld xmlns:a="http://schemas.openxmlformats.org/drawingml/2006/main" xmlns:r="http://schemas.openxmlformats.org/officeDocument/2006/relationships" xmlns:p="http://schemas.openxmlformats.org/presentationml/2006/main">
+  <p:cSld>
+    <p:spTree>
+      <p:nvGrpSpPr>
+        <p:cNvPr id="1" name=""/>
+        <p:cNvGrpSpPr/>
+        <p:nvPr/>
+      </p:nvGrpSpPr>
+      <p:grpSpPr>
+        <a:xfrm>
+          <a:off x="0" y="0"/>
+          <a:ext cx="0" cy="0"/>
+          <a:chOff x="0" y="0"/>
+          <a:chExt cx="0" cy="0"/>
+        </a:xfrm>
+      </p:grpSpPr>
+      <p:sp>
+        <p:nvSpPr>
+          <p:cNvPr id="5" name="Title 4">
+            <a:extLst>
+              <a:ext uri="{FF2B5EF4-FFF2-40B4-BE49-F238E27FC236}">
+                <a16:creationId xmlns:a16="http://schemas.microsoft.com/office/drawing/2014/main" id="{78C37FEF-0980-049B-B637-0A069E9934ED}"/>
+              </a:ext>
+            </a:extLst>
+          </p:cNvPr>
+          <p:cNvSpPr>
+            <a:spLocks noGrp="1"/>
+          </p:cNvSpPr>
+          <p:nvPr>
+            <p:ph type="title"/>
+          </p:nvPr>
+        </p:nvSpPr>
+        <p:spPr/>
+        <p:txBody>
+          <a:bodyPr/>
+          <a:lstStyle/>
+          <a:p>
+            <a:r>
+              <a:rPr lang="en-US" dirty="0"/>
+              <a:t>This Week</a:t>
+            </a:r>
+          </a:p>
+        </p:txBody>
+      </p:sp>
+      <p:sp>
+        <p:nvSpPr>
+          <p:cNvPr id="6" name="Content Placeholder 5">
+            <a:extLst>
+              <a:ext uri="{FF2B5EF4-FFF2-40B4-BE49-F238E27FC236}">
+                <a16:creationId xmlns:a16="http://schemas.microsoft.com/office/drawing/2014/main" id="{8D56C057-4D35-9942-E837-AAAA9AA425CE}"/>
+              </a:ext>
+            </a:extLst>
+          </p:cNvPr>
+          <p:cNvSpPr>
+            <a:spLocks noGrp="1"/>
+          </p:cNvSpPr>
+          <p:nvPr>
+            <p:ph idx="1"/>
+          </p:nvPr>
+        </p:nvSpPr>
+        <p:spPr/>
+        <p:txBody>
+          <a:bodyPr/>
+          <a:lstStyle/>
+          <a:p>
+            <a:pPr marL="457200" indent="-457200">
+              <a:buFont typeface="Arial" panose="020B0604020202020204" pitchFamily="34" charset="0"/>
+              <a:buChar char="•"/>
+            </a:pPr>
+            <a:r>
+              <a:rPr lang="en-US" sz="4000" b="1" dirty="0"/>
+              <a:t>HS</a:t>
+            </a:r>
+            <a:r>
+              <a:rPr lang="en-US" sz="4000" dirty="0"/>
+              <a:t>: Identify systems, draw diagrams</a:t>
+            </a:r>
+          </a:p>
+          <a:p>
+            <a:pPr marL="457200" indent="-457200">
+              <a:buFont typeface="Arial" panose="020B0604020202020204" pitchFamily="34" charset="0"/>
+              <a:buChar char="•"/>
+            </a:pPr>
+            <a:r>
+              <a:rPr lang="en-US" sz="4000" b="1" dirty="0"/>
+              <a:t>CSUF</a:t>
+            </a:r>
+            <a:r>
+              <a:rPr lang="en-US" sz="4000" dirty="0"/>
+              <a:t>: Explore chip types and systems</a:t>
+            </a:r>
+          </a:p>
+        </p:txBody>
+      </p:sp>
+    </p:spTree>
+    <p:extLst>
+      <p:ext uri="{BB962C8B-B14F-4D97-AF65-F5344CB8AC3E}">
+        <p14:creationId xmlns:p14="http://schemas.microsoft.com/office/powerpoint/2010/main" val="409843220"/>
       </p:ext>
     </p:extLst>
   </p:cSld>
@@ -13136,17 +13355,17 @@
           <a:p>
             <a:r>
               <a:rPr lang="en-US" dirty="0"/>
-              <a:t>What Is a Semiconductor Chip?</a:t>
+              <a:t>What Is a Chip?</a:t>
             </a:r>
           </a:p>
         </p:txBody>
       </p:sp>
       <p:pic>
         <p:nvPicPr>
-          <p:cNvPr id="8" name="Content Placeholder 7">
-            <a:extLst>
-              <a:ext uri="{FF2B5EF4-FFF2-40B4-BE49-F238E27FC236}">
-                <a16:creationId xmlns:a16="http://schemas.microsoft.com/office/drawing/2014/main" id="{52049887-3298-56EA-5A5B-13384DDBA187}"/>
+          <p:cNvPr id="4" name="Content Placeholder 13" descr="Diagram illustrating a central microchip connected to various electronic devices, including a smartphone, laptop, electric car, microwave, and gaming console. Arrows indicate data flow between microchip and devices, highlighting microchip's role as a key component in modern technology integration.">
+            <a:extLst>
+              <a:ext uri="{FF2B5EF4-FFF2-40B4-BE49-F238E27FC236}">
+                <a16:creationId xmlns:a16="http://schemas.microsoft.com/office/drawing/2014/main" id="{16979261-3E6C-DADB-32D5-EA06D1C84041}"/>
               </a:ext>
             </a:extLst>
           </p:cNvPr>
@@ -13161,18 +13380,19 @@
           <a:blip r:embed="rId2">
             <a:extLst>
               <a:ext uri="{28A0092B-C50C-407E-A947-70E740481C1C}">
-                <a14:useLocalDpi xmlns:a14="http://schemas.microsoft.com/office/drawing/2010/main"/>
+                <a14:useLocalDpi xmlns:a14="http://schemas.microsoft.com/office/drawing/2010/main" val="0"/>
               </a:ext>
             </a:extLst>
           </a:blip>
+          <a:srcRect l="5219" r="293" b="-1"/>
           <a:stretch>
             <a:fillRect/>
           </a:stretch>
         </p:blipFill>
         <p:spPr>
           <a:xfrm>
-            <a:off x="1428415" y="1047049"/>
-            <a:ext cx="3155761" cy="2792598"/>
+            <a:off x="373224" y="1779402"/>
+            <a:ext cx="4283075" cy="3446949"/>
           </a:xfrm>
           <a:prstGeom prst="rect">
             <a:avLst/>
@@ -13217,7 +13437,7 @@
             </a:pPr>
             <a:r>
               <a:rPr lang="en-US" sz="2200" b="1" dirty="0"/>
-              <a:t>What Is a Semiconductor Chip?</a:t>
+              <a:t>What Is a Chip?</a:t>
             </a:r>
           </a:p>
           <a:p>
@@ -13395,44 +13615,6 @@
           </a:p>
         </p:txBody>
       </p:sp>
-      <p:pic>
-        <p:nvPicPr>
-          <p:cNvPr id="5" name="Content Placeholder 13">
-            <a:extLst>
-              <a:ext uri="{FF2B5EF4-FFF2-40B4-BE49-F238E27FC236}">
-                <a16:creationId xmlns:a16="http://schemas.microsoft.com/office/drawing/2014/main" id="{16979261-3E6C-DADB-32D5-EA06D1C84041}"/>
-              </a:ext>
-            </a:extLst>
-          </p:cNvPr>
-          <p:cNvPicPr>
-            <a:picLocks noChangeAspect="1"/>
-          </p:cNvPicPr>
-          <p:nvPr/>
-        </p:nvPicPr>
-        <p:blipFill>
-          <a:blip r:embed="rId3">
-            <a:extLst>
-              <a:ext uri="{28A0092B-C50C-407E-A947-70E740481C1C}">
-                <a14:useLocalDpi xmlns:a14="http://schemas.microsoft.com/office/drawing/2010/main" val="0"/>
-              </a:ext>
-            </a:extLst>
-          </a:blip>
-          <a:srcRect l="5219" r="293" b="-1"/>
-          <a:stretch>
-            <a:fillRect/>
-          </a:stretch>
-        </p:blipFill>
-        <p:spPr>
-          <a:xfrm>
-            <a:off x="1428415" y="3794824"/>
-            <a:ext cx="3155761" cy="2538317"/>
-          </a:xfrm>
-          <a:prstGeom prst="rect">
-            <a:avLst/>
-          </a:prstGeom>
-          <a:noFill/>
-        </p:spPr>
-      </p:pic>
     </p:spTree>
     <p:extLst>
       <p:ext uri="{BB962C8B-B14F-4D97-AF65-F5344CB8AC3E}">
@@ -13599,7 +13781,7 @@
       </p:sp>
       <p:pic>
         <p:nvPicPr>
-          <p:cNvPr id="15" name="Content Placeholder 14">
+          <p:cNvPr id="15" name="Content Placeholder 14" descr="Diagram illustrating data flow from three input devices—a smartphone, camera, and Wi-Fi signal—through a central processing unit to different output displays. Outputs include a graph on a monitor, a photo of two people on a screen, and a globe representing internet or network access.">
             <a:extLst>
               <a:ext uri="{FF2B5EF4-FFF2-40B4-BE49-F238E27FC236}">
                 <a16:creationId xmlns:a16="http://schemas.microsoft.com/office/drawing/2014/main" id="{122B2909-89D5-D914-1AE8-80BE0C1FDFBA}"/>
@@ -13706,7 +13888,7 @@
       </p:sp>
       <p:pic>
         <p:nvPicPr>
-          <p:cNvPr id="6" name="Content Placeholder 5">
+          <p:cNvPr id="6" name="Content Placeholder 5" descr="Line drawing showing a fingertip holding a tiny square microchip with a magnified circular inset revealing a grid of intricate circuit patterns on the chip. The illustration highlights the microchip's miniature size and detailed internal structure, emphasizing advancements in microelectronics and nanotechnology.">
             <a:extLst>
               <a:ext uri="{FF2B5EF4-FFF2-40B4-BE49-F238E27FC236}">
                 <a16:creationId xmlns:a16="http://schemas.microsoft.com/office/drawing/2014/main" id="{4D3FD6EC-2064-F865-ABAA-E0F6DEE979E3}"/>
@@ -14118,7 +14300,7 @@
       </p:sp>
       <p:pic>
         <p:nvPicPr>
-          <p:cNvPr id="6" name="Picture 5">
+          <p:cNvPr id="6" name="Picture 5" descr="Line drawing of three microchips arranged horizontally, each containing different symbols representing electronic concepts. From left to right, chips display a circuit diagram, a waveform signal, and a wireless transmission icon with concentric curved lines emanating from an antenna.">
             <a:extLst>
               <a:ext uri="{FF2B5EF4-FFF2-40B4-BE49-F238E27FC236}">
                 <a16:creationId xmlns:a16="http://schemas.microsoft.com/office/drawing/2014/main" id="{50A62D29-672B-A53D-2B2C-623D5321FFBC}"/>
@@ -14226,7 +14408,7 @@
       </p:sp>
       <p:pic>
         <p:nvPicPr>
-          <p:cNvPr id="6" name="Content Placeholder 5">
+          <p:cNvPr id="6" name="Content Placeholder 5" descr="Line art diagram illustrating a central microchip connected to six professionals working in various scientific and technological fields, symbolizing global collaboration and data exchange. The globe at the top center with location markers emphasizes worldwide connectivity, while each person is engaged with specialized equipment such as a microscope, laptop, computer, and industrial tools, highlighting interdisciplinary innovation.">
             <a:extLst>
               <a:ext uri="{FF2B5EF4-FFF2-40B4-BE49-F238E27FC236}">
                 <a16:creationId xmlns:a16="http://schemas.microsoft.com/office/drawing/2014/main" id="{5BC860FC-528D-A978-E82C-BE9E461FA702}"/>
@@ -14605,7 +14787,7 @@
       </p:sp>
       <p:pic>
         <p:nvPicPr>
-          <p:cNvPr id="11" name="Content Placeholder 5">
+          <p:cNvPr id="11" name="Content Placeholder 5" descr="Diagram illustrating semiconductor chip manufacturing process, starting with computer code converted into logic gates, followed by photolithography on a silicon wafer, and ending with a finished microchip. Key components include a monitor displaying code, logic gate symbols, a patterned wafer, and a microchip with circuit details.">
             <a:extLst>
               <a:ext uri="{FF2B5EF4-FFF2-40B4-BE49-F238E27FC236}">
                 <a16:creationId xmlns:a16="http://schemas.microsoft.com/office/drawing/2014/main" id="{E9F66D4B-2A40-C394-736F-95A127733DB2}"/>
@@ -14644,6 +14826,525 @@
     <p:extLst>
       <p:ext uri="{BB962C8B-B14F-4D97-AF65-F5344CB8AC3E}">
         <p14:creationId xmlns:p14="http://schemas.microsoft.com/office/powerpoint/2010/main" val="2080160352"/>
+      </p:ext>
+    </p:extLst>
+  </p:cSld>
+  <p:clrMapOvr>
+    <a:masterClrMapping/>
+  </p:clrMapOvr>
+</p:sld>
+</file>
+
+<file path=ppt/slides/slide8.xml><?xml version="1.0" encoding="utf-8"?>
+<p:sld xmlns:a="http://schemas.openxmlformats.org/drawingml/2006/main" xmlns:r="http://schemas.openxmlformats.org/officeDocument/2006/relationships" xmlns:p="http://schemas.openxmlformats.org/presentationml/2006/main">
+  <p:cSld>
+    <p:spTree>
+      <p:nvGrpSpPr>
+        <p:cNvPr id="1" name="">
+          <a:extLst>
+            <a:ext uri="{FF2B5EF4-FFF2-40B4-BE49-F238E27FC236}">
+              <a16:creationId xmlns:a16="http://schemas.microsoft.com/office/drawing/2014/main" id="{CE412D0E-DBA5-3FF5-8652-E4522FC25055}"/>
+            </a:ext>
+          </a:extLst>
+        </p:cNvPr>
+        <p:cNvGrpSpPr/>
+        <p:nvPr/>
+      </p:nvGrpSpPr>
+      <p:grpSpPr>
+        <a:xfrm>
+          <a:off x="0" y="0"/>
+          <a:ext cx="0" cy="0"/>
+          <a:chOff x="0" y="0"/>
+          <a:chExt cx="0" cy="0"/>
+        </a:xfrm>
+      </p:grpSpPr>
+      <p:sp>
+        <p:nvSpPr>
+          <p:cNvPr id="2" name="Title 1">
+            <a:extLst>
+              <a:ext uri="{FF2B5EF4-FFF2-40B4-BE49-F238E27FC236}">
+                <a16:creationId xmlns:a16="http://schemas.microsoft.com/office/drawing/2014/main" id="{26BE7C78-EA59-3A72-417D-AFEBD5F748D2}"/>
+              </a:ext>
+            </a:extLst>
+          </p:cNvPr>
+          <p:cNvSpPr>
+            <a:spLocks noGrp="1"/>
+          </p:cNvSpPr>
+          <p:nvPr>
+            <p:ph type="title"/>
+          </p:nvPr>
+        </p:nvSpPr>
+        <p:spPr/>
+        <p:txBody>
+          <a:bodyPr anchor="ctr">
+            <a:normAutofit/>
+          </a:bodyPr>
+          <a:lstStyle/>
+          <a:p>
+            <a:r>
+              <a:rPr lang="en-US" dirty="0"/>
+              <a:t>System Thinking Example</a:t>
+            </a:r>
+          </a:p>
+        </p:txBody>
+      </p:sp>
+      <p:sp>
+        <p:nvSpPr>
+          <p:cNvPr id="10" name="Content Placeholder 2">
+            <a:extLst>
+              <a:ext uri="{FF2B5EF4-FFF2-40B4-BE49-F238E27FC236}">
+                <a16:creationId xmlns:a16="http://schemas.microsoft.com/office/drawing/2014/main" id="{18A8AE36-CEC0-E0E9-5C0C-22A2ABA7F2C4}"/>
+              </a:ext>
+            </a:extLst>
+          </p:cNvPr>
+          <p:cNvSpPr>
+            <a:spLocks noGrp="1"/>
+          </p:cNvSpPr>
+          <p:nvPr>
+            <p:ph sz="half" idx="1"/>
+          </p:nvPr>
+        </p:nvSpPr>
+        <p:spPr>
+          <a:xfrm>
+            <a:off x="457200" y="1600200"/>
+            <a:ext cx="5524500" cy="4639235"/>
+          </a:xfrm>
+        </p:spPr>
+        <p:txBody>
+          <a:bodyPr/>
+          <a:lstStyle/>
+          <a:p>
+            <a:r>
+              <a:rPr lang="en-US" sz="2000" b="1" dirty="0"/>
+              <a:t>Smart Thermostat</a:t>
+            </a:r>
+          </a:p>
+          <a:p>
+            <a:pPr lvl="1"/>
+            <a:r>
+              <a:rPr lang="en-US" sz="2000" dirty="0"/>
+              <a:t>Inputs</a:t>
+            </a:r>
+          </a:p>
+          <a:p>
+            <a:pPr lvl="1"/>
+            <a:r>
+              <a:rPr lang="en-US" sz="2000" dirty="0"/>
+              <a:t>Room temperature sensor</a:t>
+            </a:r>
+          </a:p>
+          <a:p>
+            <a:pPr lvl="1"/>
+            <a:r>
+              <a:rPr lang="en-US" sz="2000" dirty="0"/>
+              <a:t>User-set temperature</a:t>
+            </a:r>
+          </a:p>
+          <a:p>
+            <a:pPr lvl="1"/>
+            <a:r>
+              <a:rPr lang="en-US" sz="2000" dirty="0"/>
+              <a:t>Time of day</a:t>
+            </a:r>
+          </a:p>
+          <a:p>
+            <a:pPr lvl="1"/>
+            <a:r>
+              <a:rPr lang="en-US" sz="2000" dirty="0"/>
+              <a:t>Occupancy sensor</a:t>
+            </a:r>
+          </a:p>
+          <a:p>
+            <a:r>
+              <a:rPr lang="en-US" sz="2000" b="1" dirty="0"/>
+              <a:t>Rules / Processing</a:t>
+            </a:r>
+          </a:p>
+          <a:p>
+            <a:pPr lvl="1"/>
+            <a:r>
+              <a:rPr lang="en-US" sz="2000" dirty="0"/>
+              <a:t>Compare current temperature to setpoint</a:t>
+            </a:r>
+          </a:p>
+          <a:p>
+            <a:pPr lvl="2"/>
+            <a:r>
+              <a:rPr lang="en-US" sz="2000" dirty="0"/>
+              <a:t>If temp &lt; setpoint → turn heat on</a:t>
+            </a:r>
+          </a:p>
+          <a:p>
+            <a:pPr lvl="2"/>
+            <a:r>
+              <a:rPr lang="en-US" sz="2000" dirty="0"/>
+              <a:t>If temp &gt; setpoint → turn cooling on</a:t>
+            </a:r>
+          </a:p>
+          <a:p>
+            <a:pPr lvl="1"/>
+            <a:r>
+              <a:rPr lang="en-US" sz="2000" dirty="0"/>
+              <a:t>Schedule-based control logic</a:t>
+            </a:r>
+          </a:p>
+          <a:p>
+            <a:pPr lvl="1"/>
+            <a:r>
+              <a:rPr lang="en-US" sz="2000" dirty="0"/>
+              <a:t>Energy optimization algorithms</a:t>
+            </a:r>
+          </a:p>
+        </p:txBody>
+      </p:sp>
+      <p:sp>
+        <p:nvSpPr>
+          <p:cNvPr id="8" name="Content Placeholder 7">
+            <a:extLst>
+              <a:ext uri="{FF2B5EF4-FFF2-40B4-BE49-F238E27FC236}">
+                <a16:creationId xmlns:a16="http://schemas.microsoft.com/office/drawing/2014/main" id="{58CA105E-E4EB-06D3-1294-70887444CFFD}"/>
+              </a:ext>
+            </a:extLst>
+          </p:cNvPr>
+          <p:cNvSpPr>
+            <a:spLocks noGrp="1"/>
+          </p:cNvSpPr>
+          <p:nvPr>
+            <p:ph sz="half" idx="13"/>
+          </p:nvPr>
+        </p:nvSpPr>
+        <p:spPr>
+          <a:xfrm>
+            <a:off x="6202466" y="1600200"/>
+            <a:ext cx="5524500" cy="1761565"/>
+          </a:xfrm>
+        </p:spPr>
+        <p:txBody>
+          <a:bodyPr/>
+          <a:lstStyle/>
+          <a:p>
+            <a:r>
+              <a:rPr lang="en-US" sz="2000" b="1" dirty="0"/>
+              <a:t>Outputs</a:t>
+            </a:r>
+          </a:p>
+          <a:p>
+            <a:pPr lvl="1"/>
+            <a:r>
+              <a:rPr lang="en-US" sz="2000" dirty="0"/>
+              <a:t>Control signal to HVAC system</a:t>
+            </a:r>
+          </a:p>
+          <a:p>
+            <a:pPr lvl="1"/>
+            <a:r>
+              <a:rPr lang="en-US" sz="2000" dirty="0"/>
+              <a:t>Display updates</a:t>
+            </a:r>
+          </a:p>
+          <a:p>
+            <a:pPr lvl="1"/>
+            <a:r>
+              <a:rPr lang="en-US" sz="2000" dirty="0" err="1"/>
+              <a:t>WiFi</a:t>
+            </a:r>
+            <a:r>
+              <a:rPr lang="en-US" sz="2000" dirty="0"/>
+              <a:t> communication to phone app</a:t>
+            </a:r>
+          </a:p>
+        </p:txBody>
+      </p:sp>
+      <p:pic>
+        <p:nvPicPr>
+          <p:cNvPr id="13" name="Picture 12" descr="Diagram illustrating a smart thermostat system controlling home temperature remotely. It shows a thermometer sending data to a thermostat set at 72°, which wirelessly communicates with an HVAC unit and a smartphone displaying the same temperature.">
+            <a:extLst>
+              <a:ext uri="{FF2B5EF4-FFF2-40B4-BE49-F238E27FC236}">
+                <a16:creationId xmlns:a16="http://schemas.microsoft.com/office/drawing/2014/main" id="{E547E20B-8526-A21E-AA67-A91DDD3F6E49}"/>
+              </a:ext>
+            </a:extLst>
+          </p:cNvPr>
+          <p:cNvPicPr>
+            <a:picLocks noChangeAspect="1"/>
+          </p:cNvPicPr>
+          <p:nvPr/>
+        </p:nvPicPr>
+        <p:blipFill>
+          <a:blip r:embed="rId2"/>
+          <a:stretch>
+            <a:fillRect/>
+          </a:stretch>
+        </p:blipFill>
+        <p:spPr>
+          <a:xfrm>
+            <a:off x="6573941" y="3690660"/>
+            <a:ext cx="4781550" cy="1466850"/>
+          </a:xfrm>
+          <a:prstGeom prst="rect">
+            <a:avLst/>
+          </a:prstGeom>
+        </p:spPr>
+      </p:pic>
+    </p:spTree>
+    <p:extLst>
+      <p:ext uri="{BB962C8B-B14F-4D97-AF65-F5344CB8AC3E}">
+        <p14:creationId xmlns:p14="http://schemas.microsoft.com/office/powerpoint/2010/main" val="583567288"/>
+      </p:ext>
+    </p:extLst>
+  </p:cSld>
+  <p:clrMapOvr>
+    <a:masterClrMapping/>
+  </p:clrMapOvr>
+</p:sld>
+</file>
+
+<file path=ppt/slides/slide9.xml><?xml version="1.0" encoding="utf-8"?>
+<p:sld xmlns:a="http://schemas.openxmlformats.org/drawingml/2006/main" xmlns:r="http://schemas.openxmlformats.org/officeDocument/2006/relationships" xmlns:p="http://schemas.openxmlformats.org/presentationml/2006/main">
+  <p:cSld>
+    <p:spTree>
+      <p:nvGrpSpPr>
+        <p:cNvPr id="1" name="">
+          <a:extLst>
+            <a:ext uri="{FF2B5EF4-FFF2-40B4-BE49-F238E27FC236}">
+              <a16:creationId xmlns:a16="http://schemas.microsoft.com/office/drawing/2014/main" id="{9ACFEFDD-E910-122F-2602-57251DF9889F}"/>
+            </a:ext>
+          </a:extLst>
+        </p:cNvPr>
+        <p:cNvGrpSpPr/>
+        <p:nvPr/>
+      </p:nvGrpSpPr>
+      <p:grpSpPr>
+        <a:xfrm>
+          <a:off x="0" y="0"/>
+          <a:ext cx="0" cy="0"/>
+          <a:chOff x="0" y="0"/>
+          <a:chExt cx="0" cy="0"/>
+        </a:xfrm>
+      </p:grpSpPr>
+      <p:sp>
+        <p:nvSpPr>
+          <p:cNvPr id="2" name="Title 1">
+            <a:extLst>
+              <a:ext uri="{FF2B5EF4-FFF2-40B4-BE49-F238E27FC236}">
+                <a16:creationId xmlns:a16="http://schemas.microsoft.com/office/drawing/2014/main" id="{BEC63986-C044-6BC5-6CD2-F6B9E25B9A8D}"/>
+              </a:ext>
+            </a:extLst>
+          </p:cNvPr>
+          <p:cNvSpPr>
+            <a:spLocks noGrp="1"/>
+          </p:cNvSpPr>
+          <p:nvPr>
+            <p:ph type="title"/>
+          </p:nvPr>
+        </p:nvSpPr>
+        <p:spPr/>
+        <p:txBody>
+          <a:bodyPr anchor="ctr">
+            <a:normAutofit/>
+          </a:bodyPr>
+          <a:lstStyle/>
+          <a:p>
+            <a:r>
+              <a:rPr lang="en-US" dirty="0"/>
+              <a:t>Key Takeaways: What Is a Chip?</a:t>
+            </a:r>
+          </a:p>
+        </p:txBody>
+      </p:sp>
+      <p:sp>
+        <p:nvSpPr>
+          <p:cNvPr id="7" name="Content Placeholder 6">
+            <a:extLst>
+              <a:ext uri="{FF2B5EF4-FFF2-40B4-BE49-F238E27FC236}">
+                <a16:creationId xmlns:a16="http://schemas.microsoft.com/office/drawing/2014/main" id="{0AEE2686-837D-DDEC-BD0A-93A0764B2CFC}"/>
+              </a:ext>
+            </a:extLst>
+          </p:cNvPr>
+          <p:cNvSpPr>
+            <a:spLocks noGrp="1"/>
+          </p:cNvSpPr>
+          <p:nvPr>
+            <p:ph sz="half" idx="1"/>
+          </p:nvPr>
+        </p:nvSpPr>
+        <p:spPr>
+          <a:xfrm>
+            <a:off x="457200" y="1517905"/>
+            <a:ext cx="5524500" cy="2090000"/>
+          </a:xfrm>
+        </p:spPr>
+        <p:txBody>
+          <a:bodyPr/>
+          <a:lstStyle/>
+          <a:p>
+            <a:r>
+              <a:rPr lang="en-US" sz="2000" b="1" dirty="0"/>
+              <a:t>A Semiconductor Chip Is:</a:t>
+            </a:r>
+          </a:p>
+          <a:p>
+            <a:pPr lvl="1"/>
+            <a:r>
+              <a:rPr lang="en-US" sz="2000" dirty="0"/>
+              <a:t>A physical device built from billions of transistors</a:t>
+            </a:r>
+          </a:p>
+          <a:p>
+            <a:pPr lvl="1"/>
+            <a:r>
+              <a:rPr lang="en-US" sz="2000" dirty="0"/>
+              <a:t>A system that processes electrical signals</a:t>
+            </a:r>
+          </a:p>
+          <a:p>
+            <a:pPr lvl="1"/>
+            <a:r>
+              <a:rPr lang="en-US" sz="2000" dirty="0"/>
+              <a:t>A rule-following machine designed by engineers</a:t>
+            </a:r>
+          </a:p>
+          <a:p>
+            <a:endParaRPr lang="en-US" sz="2000" dirty="0"/>
+          </a:p>
+        </p:txBody>
+      </p:sp>
+      <p:pic>
+        <p:nvPicPr>
+          <p:cNvPr id="10" name="Picture 9" descr="Diagram illustrating a microchip design integrating three MOSFET transistor symbols connected to a smartphone displaying a temperature of 72° and a rocket with flames. The diagram highlights the microchip's role in interfacing electronic components with devices for applications like temperature monitoring and aerospace technology.">
+            <a:extLst>
+              <a:ext uri="{FF2B5EF4-FFF2-40B4-BE49-F238E27FC236}">
+                <a16:creationId xmlns:a16="http://schemas.microsoft.com/office/drawing/2014/main" id="{5A3B52A0-77F2-31F3-E54A-BF168EA8F5DF}"/>
+              </a:ext>
+            </a:extLst>
+          </p:cNvPr>
+          <p:cNvPicPr>
+            <a:picLocks noChangeAspect="1"/>
+          </p:cNvPicPr>
+          <p:nvPr/>
+        </p:nvPicPr>
+        <p:blipFill>
+          <a:blip r:embed="rId2">
+            <a:extLst>
+              <a:ext uri="{28A0092B-C50C-407E-A947-70E740481C1C}">
+                <a14:useLocalDpi xmlns:a14="http://schemas.microsoft.com/office/drawing/2010/main" val="0"/>
+              </a:ext>
+            </a:extLst>
+          </a:blip>
+          <a:srcRect/>
+          <a:stretch>
+            <a:fillRect/>
+          </a:stretch>
+        </p:blipFill>
+        <p:spPr>
+          <a:xfrm>
+            <a:off x="1133060" y="3737112"/>
+            <a:ext cx="3840266" cy="2530523"/>
+          </a:xfrm>
+          <a:prstGeom prst="rect">
+            <a:avLst/>
+          </a:prstGeom>
+        </p:spPr>
+      </p:pic>
+      <p:sp>
+        <p:nvSpPr>
+          <p:cNvPr id="8" name="Content Placeholder 7">
+            <a:extLst>
+              <a:ext uri="{FF2B5EF4-FFF2-40B4-BE49-F238E27FC236}">
+                <a16:creationId xmlns:a16="http://schemas.microsoft.com/office/drawing/2014/main" id="{144AD2C7-F89D-0969-6489-58970AAE257B}"/>
+              </a:ext>
+            </a:extLst>
+          </p:cNvPr>
+          <p:cNvSpPr>
+            <a:spLocks noGrp="1"/>
+          </p:cNvSpPr>
+          <p:nvPr>
+            <p:ph sz="half" idx="13"/>
+          </p:nvPr>
+        </p:nvSpPr>
+        <p:spPr>
+          <a:xfrm>
+            <a:off x="6202466" y="1517904"/>
+            <a:ext cx="5524500" cy="4749731"/>
+          </a:xfrm>
+        </p:spPr>
+        <p:txBody>
+          <a:bodyPr/>
+          <a:lstStyle/>
+          <a:p>
+            <a:r>
+              <a:rPr lang="en-US" sz="2000" b="1" dirty="0"/>
+              <a:t>Every Chip Follows the Same Pattern:</a:t>
+            </a:r>
+          </a:p>
+          <a:p>
+            <a:pPr lvl="1"/>
+            <a:r>
+              <a:rPr lang="en-US" sz="2000" dirty="0"/>
+              <a:t>Inputs → Rules → Outputs</a:t>
+            </a:r>
+          </a:p>
+          <a:p>
+            <a:pPr lvl="1"/>
+            <a:r>
+              <a:rPr lang="en-US" sz="2000" dirty="0"/>
+              <a:t>Sensors and data come in</a:t>
+            </a:r>
+          </a:p>
+          <a:p>
+            <a:pPr lvl="1"/>
+            <a:r>
+              <a:rPr lang="en-US" sz="2000" dirty="0"/>
+              <a:t>Logic and physics process the signals</a:t>
+            </a:r>
+          </a:p>
+          <a:p>
+            <a:pPr lvl="1"/>
+            <a:r>
+              <a:rPr lang="en-US" sz="2000" dirty="0"/>
+              <a:t>Actions or information come out</a:t>
+            </a:r>
+            <a:endParaRPr lang="en-US" sz="2000" b="1" dirty="0"/>
+          </a:p>
+          <a:p>
+            <a:r>
+              <a:rPr lang="en-US" sz="2000" b="1" dirty="0"/>
+              <a:t>Modern Products Contain Many Chips</a:t>
+            </a:r>
+          </a:p>
+          <a:p>
+            <a:pPr lvl="1"/>
+            <a:r>
+              <a:rPr lang="en-US" sz="2000" dirty="0"/>
+              <a:t>Digital chips for logic and computation</a:t>
+            </a:r>
+          </a:p>
+          <a:p>
+            <a:pPr lvl="1"/>
+            <a:r>
+              <a:rPr lang="en-US" sz="2000" dirty="0"/>
+              <a:t>Analog chips for real-world signals</a:t>
+            </a:r>
+          </a:p>
+          <a:p>
+            <a:pPr lvl="1"/>
+            <a:r>
+              <a:rPr lang="en-US" sz="2000" dirty="0"/>
+              <a:t>RF chips for wireless communication</a:t>
+            </a:r>
+          </a:p>
+          <a:p>
+            <a:pPr lvl="1"/>
+            <a:r>
+              <a:rPr lang="en-US" sz="2000" dirty="0"/>
+              <a:t>Power chips for energy control</a:t>
+            </a:r>
+          </a:p>
+        </p:txBody>
+      </p:sp>
+    </p:spTree>
+    <p:extLst>
+      <p:ext uri="{BB962C8B-B14F-4D97-AF65-F5344CB8AC3E}">
+        <p14:creationId xmlns:p14="http://schemas.microsoft.com/office/powerpoint/2010/main" val="2346093389"/>
       </p:ext>
     </p:extLst>
   </p:cSld>

</xml_diff>

<commit_message>
03-28-26 - Update module 1
</commit_message>
<xml_diff>
--- a/lectures/module_01_what_is_a_chip.pptx
+++ b/lectures/module_01_what_is_a_chip.pptx
@@ -225,7 +225,7 @@
           <a:p>
             <a:fld id="{235382CB-D6B4-48E5-AFFD-4242D787BD27}" type="datetime2">
               <a:rPr lang="en-US" smtClean="0"/>
-              <a:t>Thursday, March 26, 2026</a:t>
+              <a:t>Friday, March 27, 2026</a:t>
             </a:fld>
             <a:endParaRPr lang="en-US"/>
           </a:p>
@@ -409,7 +409,7 @@
           <a:p>
             <a:fld id="{F76BFB3A-AF09-4935-935F-AADA8F949CAB}" type="datetime2">
               <a:rPr lang="en-US" smtClean="0"/>
-              <a:t>Thursday, March 26, 2026</a:t>
+              <a:t>Friday, March 27, 2026</a:t>
             </a:fld>
             <a:endParaRPr lang="en-US"/>
           </a:p>
@@ -13189,6 +13189,58 @@
           </a:ln>
         </p:spPr>
       </p:pic>
+      <p:sp>
+        <p:nvSpPr>
+          <p:cNvPr id="2" name="TextBox 1">
+            <a:extLst>
+              <a:ext uri="{FF2B5EF4-FFF2-40B4-BE49-F238E27FC236}">
+                <a16:creationId xmlns:a16="http://schemas.microsoft.com/office/drawing/2014/main" id="{7D56E876-1E3D-5087-B734-69927B4361C6}"/>
+              </a:ext>
+            </a:extLst>
+          </p:cNvPr>
+          <p:cNvSpPr txBox="1"/>
+          <p:nvPr/>
+        </p:nvSpPr>
+        <p:spPr>
+          <a:xfrm>
+            <a:off x="10151706" y="6484776"/>
+            <a:ext cx="1861985" cy="307777"/>
+          </a:xfrm>
+          <a:prstGeom prst="rect">
+            <a:avLst/>
+          </a:prstGeom>
+          <a:noFill/>
+        </p:spPr>
+        <p:txBody>
+          <a:bodyPr wrap="none" rtlCol="0">
+            <a:spAutoFit/>
+          </a:bodyPr>
+          <a:lstStyle/>
+          <a:p>
+            <a:r>
+              <a:rPr lang="en-US" sz="1400" dirty="0">
+                <a:solidFill>
+                  <a:schemeClr val="bg1"/>
+                </a:solidFill>
+              </a:rPr>
+              <a:t>Source: Tiny </a:t>
+            </a:r>
+            <a:r>
+              <a:rPr lang="en-US" sz="1400" dirty="0" err="1">
+                <a:solidFill>
+                  <a:schemeClr val="bg1"/>
+                </a:solidFill>
+              </a:rPr>
+              <a:t>Tapeout</a:t>
+            </a:r>
+            <a:endParaRPr lang="en-US" sz="1400" dirty="0">
+              <a:solidFill>
+                <a:schemeClr val="bg1"/>
+              </a:solidFill>
+            </a:endParaRPr>
+          </a:p>
+        </p:txBody>
+      </p:sp>
     </p:spTree>
     <p:extLst>
       <p:ext uri="{BB962C8B-B14F-4D97-AF65-F5344CB8AC3E}">

</xml_diff>